<commit_message>
final term paper start
</commit_message>
<xml_diff>
--- a/termpaper/ppt/pitch/DiPietrantonio_ME5311_TermPitch.pptx
+++ b/termpaper/ppt/pitch/DiPietrantonio_ME5311_TermPitch.pptx
@@ -238,7 +238,7 @@
           <a:p>
             <a:fld id="{B21E4BF6-4F13-4DA6-8587-A4F57D0EB927}" type="datetimeFigureOut">
               <a:rPr lang="en-US" smtClean="0"/>
-              <a:t>4/25/2026</a:t>
+              <a:t>4/27/2026</a:t>
             </a:fld>
             <a:endParaRPr lang="en-US"/>
           </a:p>
@@ -2206,31 +2206,7 @@
                 <a:ea typeface="+mn-ea"/>
                 <a:cs typeface="+mn-cs"/>
               </a:rPr>
-              <a:t>This plot was created to help us visualize those concepts of drift and </a:t>
-            </a:r>
-            <a:r>
-              <a:rPr lang="en-US" sz="1200" b="0" kern="1200" dirty="0" err="1">
-                <a:solidFill>
-                  <a:schemeClr val="tx1"/>
-                </a:solidFill>
-                <a:effectLst/>
-                <a:latin typeface="+mn-lt"/>
-                <a:ea typeface="+mn-ea"/>
-                <a:cs typeface="+mn-cs"/>
-              </a:rPr>
-              <a:t>difusion</a:t>
-            </a:r>
-            <a:r>
-              <a:rPr lang="en-US" sz="1200" b="0" kern="1200" dirty="0">
-                <a:solidFill>
-                  <a:schemeClr val="tx1"/>
-                </a:solidFill>
-                <a:effectLst/>
-                <a:latin typeface="+mn-lt"/>
-                <a:ea typeface="+mn-ea"/>
-                <a:cs typeface="+mn-cs"/>
-              </a:rPr>
-              <a:t>.</a:t>
+              <a:t>This plot was created to help us visualize those concepts of drift and diffusion.</a:t>
             </a:r>
           </a:p>
           <a:p>
@@ -9193,14 +9169,14 @@
           <p:nvPr>
             <p:extLst>
               <p:ext uri="{D42A27DB-BD31-4B8C-83A1-F6EECF244321}">
-                <p14:modId xmlns:p14="http://schemas.microsoft.com/office/powerpoint/2010/main" val="221504522"/>
+                <p14:modId xmlns:p14="http://schemas.microsoft.com/office/powerpoint/2010/main" val="883024609"/>
               </p:ext>
             </p:extLst>
           </p:nvPr>
         </p:nvGraphicFramePr>
         <p:xfrm>
           <a:off x="1463040" y="4177534"/>
-          <a:ext cx="9265920" cy="2560320"/>
+          <a:ext cx="9265920" cy="2194560"/>
         </p:xfrm>
         <a:graphic>
           <a:graphicData uri="http://schemas.openxmlformats.org/drawingml/2006/table">
@@ -9931,143 +9907,6 @@
                 <a:extLst>
                   <a:ext uri="{0D108BD9-81ED-4DB2-BD59-A6C34878D82A}">
                     <a16:rowId xmlns:a16="http://schemas.microsoft.com/office/drawing/2014/main" val="2236625790"/>
-                  </a:ext>
-                </a:extLst>
-              </a:tr>
-              <a:tr h="345440">
-                <a:tc>
-                  <a:txBody>
-                    <a:bodyPr/>
-                    <a:lstStyle/>
-                    <a:p>
-                      <a:pPr marL="0" indent="0" algn="ctr">
-                        <a:buNone/>
-                      </a:pPr>
-                      <a:r>
-                        <a:rPr lang="en-US" sz="1600" dirty="0">
-                          <a:solidFill>
-                            <a:srgbClr val="2D3748"/>
-                          </a:solidFill>
-                          <a:latin typeface="Calibri" pitchFamily="34" charset="0"/>
-                          <a:ea typeface="Calibri" pitchFamily="34" charset="-122"/>
-                          <a:cs typeface="Calibri" pitchFamily="34" charset="-120"/>
-                        </a:rPr>
-                        <a:t>BSM PDE</a:t>
-                      </a:r>
-                      <a:endParaRPr lang="en-US" sz="1600" dirty="0">
-                        <a:latin typeface="Calibri" charset="0"/>
-                        <a:ea typeface="Calibri" charset="0"/>
-                        <a:cs typeface="Calibri" charset="0"/>
-                      </a:endParaRPr>
-                    </a:p>
-                  </a:txBody>
-                  <a:tcPr marL="121920" marR="121920" marT="60960" marB="60960">
-                    <a:lnL w="6350" cap="flat" cmpd="sng" algn="ctr">
-                      <a:solidFill>
-                        <a:srgbClr val="CCCCCC"/>
-                      </a:solidFill>
-                      <a:prstDash val="solid"/>
-                      <a:round/>
-                      <a:headEnd type="none" w="med" len="med"/>
-                      <a:tailEnd type="none" w="med" len="med"/>
-                    </a:lnL>
-                    <a:lnR w="6350" cap="flat" cmpd="sng" algn="ctr">
-                      <a:solidFill>
-                        <a:srgbClr val="CCCCCC"/>
-                      </a:solidFill>
-                      <a:prstDash val="solid"/>
-                      <a:round/>
-                      <a:headEnd type="none" w="med" len="med"/>
-                      <a:tailEnd type="none" w="med" len="med"/>
-                    </a:lnR>
-                    <a:lnT w="6350" cap="flat" cmpd="sng" algn="ctr">
-                      <a:solidFill>
-                        <a:srgbClr val="CCCCCC"/>
-                      </a:solidFill>
-                      <a:prstDash val="solid"/>
-                      <a:round/>
-                      <a:headEnd type="none" w="med" len="med"/>
-                      <a:tailEnd type="none" w="med" len="med"/>
-                    </a:lnT>
-                    <a:lnB w="6350" cap="flat" cmpd="sng" algn="ctr">
-                      <a:solidFill>
-                        <a:srgbClr val="CCCCCC"/>
-                      </a:solidFill>
-                      <a:prstDash val="solid"/>
-                      <a:round/>
-                      <a:headEnd type="none" w="med" len="med"/>
-                      <a:tailEnd type="none" w="med" len="med"/>
-                    </a:lnB>
-                  </a:tcPr>
-                </a:tc>
-                <a:tc>
-                  <a:txBody>
-                    <a:bodyPr/>
-                    <a:lstStyle/>
-                    <a:p>
-                      <a:pPr marL="0" indent="0" algn="ctr">
-                        <a:buNone/>
-                      </a:pPr>
-                      <a:r>
-                        <a:rPr lang="en-US" sz="1600" dirty="0">
-                          <a:solidFill>
-                            <a:srgbClr val="2D3748"/>
-                          </a:solidFill>
-                          <a:latin typeface="Calibri" pitchFamily="34" charset="0"/>
-                          <a:ea typeface="Calibri" pitchFamily="34" charset="-122"/>
-                          <a:cs typeface="Calibri" pitchFamily="34" charset="-120"/>
-                        </a:rPr>
-                        <a:t>Fokker-Planck (forward Kolmogorov)</a:t>
-                      </a:r>
-                      <a:endParaRPr lang="en-US" sz="1600" dirty="0">
-                        <a:latin typeface="Calibri" charset="0"/>
-                        <a:ea typeface="Calibri" charset="0"/>
-                        <a:cs typeface="Calibri" charset="0"/>
-                      </a:endParaRPr>
-                    </a:p>
-                  </a:txBody>
-                  <a:tcPr marL="121920" marR="121920" marT="60960" marB="60960">
-                    <a:lnL w="6350" cap="flat" cmpd="sng" algn="ctr">
-                      <a:solidFill>
-                        <a:srgbClr val="CCCCCC"/>
-                      </a:solidFill>
-                      <a:prstDash val="solid"/>
-                      <a:round/>
-                      <a:headEnd type="none" w="med" len="med"/>
-                      <a:tailEnd type="none" w="med" len="med"/>
-                    </a:lnL>
-                    <a:lnR w="6350" cap="flat" cmpd="sng" algn="ctr">
-                      <a:solidFill>
-                        <a:srgbClr val="CCCCCC"/>
-                      </a:solidFill>
-                      <a:prstDash val="solid"/>
-                      <a:round/>
-                      <a:headEnd type="none" w="med" len="med"/>
-                      <a:tailEnd type="none" w="med" len="med"/>
-                    </a:lnR>
-                    <a:lnT w="6350" cap="flat" cmpd="sng" algn="ctr">
-                      <a:solidFill>
-                        <a:srgbClr val="CCCCCC"/>
-                      </a:solidFill>
-                      <a:prstDash val="solid"/>
-                      <a:round/>
-                      <a:headEnd type="none" w="med" len="med"/>
-                      <a:tailEnd type="none" w="med" len="med"/>
-                    </a:lnT>
-                    <a:lnB w="6350" cap="flat" cmpd="sng" algn="ctr">
-                      <a:solidFill>
-                        <a:srgbClr val="CCCCCC"/>
-                      </a:solidFill>
-                      <a:prstDash val="solid"/>
-                      <a:round/>
-                      <a:headEnd type="none" w="med" len="med"/>
-                      <a:tailEnd type="none" w="med" len="med"/>
-                    </a:lnB>
-                  </a:tcPr>
-                </a:tc>
-                <a:extLst>
-                  <a:ext uri="{0D108BD9-81ED-4DB2-BD59-A6C34878D82A}">
-                    <a16:rowId xmlns:a16="http://schemas.microsoft.com/office/drawing/2014/main" val="10004"/>
                   </a:ext>
                 </a:extLst>
               </a:tr>
@@ -12466,41 +12305,7 @@
                 <a:ea typeface="Calibri" pitchFamily="34" charset="-122"/>
                 <a:cs typeface="Calibri" pitchFamily="34" charset="-120"/>
               </a:rPr>
-              <a:t>Monte Carlo particle simulations can reproduce the results obtained </a:t>
-            </a:r>
-            <a:r>
-              <a:rPr kumimoji="0" lang="en-US" sz="1600" b="0" i="0" u="none" strike="noStrike" kern="1200" cap="none" spc="0" normalizeH="0" baseline="0" noProof="0">
-                <a:ln>
-                  <a:noFill/>
-                </a:ln>
-                <a:solidFill>
-                  <a:srgbClr val="CADCFC"/>
-                </a:solidFill>
-                <a:effectLst/>
-                <a:uLnTx/>
-                <a:uFillTx/>
-                <a:latin typeface="Calibri" panose="020F0502020204030204"/>
-                <a:ea typeface="Calibri" pitchFamily="34" charset="-122"/>
-                <a:cs typeface="Calibri" pitchFamily="34" charset="-120"/>
-              </a:rPr>
-              <a:t>from analytical </a:t>
-            </a:r>
-            <a:r>
-              <a:rPr kumimoji="0" lang="en-US" sz="1600" b="0" i="0" u="none" strike="noStrike" kern="1200" cap="none" spc="0" normalizeH="0" baseline="0" noProof="0" dirty="0">
-                <a:ln>
-                  <a:noFill/>
-                </a:ln>
-                <a:solidFill>
-                  <a:srgbClr val="CADCFC"/>
-                </a:solidFill>
-                <a:effectLst/>
-                <a:uLnTx/>
-                <a:uFillTx/>
-                <a:latin typeface="Calibri" panose="020F0502020204030204"/>
-                <a:ea typeface="Calibri" pitchFamily="34" charset="-122"/>
-                <a:cs typeface="Calibri" pitchFamily="34" charset="-120"/>
-              </a:rPr>
-              <a:t>probability density functions.</a:t>
+              <a:t>Monte Carlo particle simulations can reproduce the results obtained from analytical probability density functions.</a:t>
             </a:r>
             <a:endParaRPr kumimoji="0" lang="en-US" sz="1600" b="0" i="0" u="none" strike="noStrike" kern="1200" cap="none" spc="0" normalizeH="0" baseline="0" noProof="0" dirty="0">
               <a:ln>

</xml_diff>